<commit_message>
add data banks to resources site
</commit_message>
<xml_diff>
--- a/InvisibleDetergents/parts_or_populations.pptx
+++ b/InvisibleDetergents/parts_or_populations.pptx
@@ -4909,8 +4909,8 @@
           </a:p>
         </p:txBody>
       </p:sp>
-      <mc:AlternateContent xmlns:mc="http://schemas.openxmlformats.org/markup-compatibility/2006">
-        <mc:Choice xmlns:a14="http://schemas.microsoft.com/office/drawing/2010/main" Requires="a14">
+      <mc:AlternateContent xmlns:mc="http://schemas.openxmlformats.org/markup-compatibility/2006" xmlns:a14="http://schemas.microsoft.com/office/drawing/2010/main">
+        <mc:Choice Requires="a14">
           <p:sp>
             <p:nvSpPr>
               <p:cNvPr id="70" name="TextBox 69">
@@ -4939,6 +4939,7 @@
               </a:bodyPr>
               <a:lstStyle/>
               <a:p>
+                <a:pPr/>
                 <a14:m>
                   <m:oMathPara xmlns:m="http://schemas.openxmlformats.org/officeDocument/2006/math">
                     <m:oMathParaPr>
@@ -5105,7 +5106,7 @@
             </p:txBody>
           </p:sp>
         </mc:Choice>
-        <mc:Fallback>
+        <mc:Fallback xmlns="">
           <p:sp>
             <p:nvSpPr>
               <p:cNvPr id="70" name="TextBox 69">
@@ -5150,8 +5151,8 @@
           </p:sp>
         </mc:Fallback>
       </mc:AlternateContent>
-      <mc:AlternateContent xmlns:mc="http://schemas.openxmlformats.org/markup-compatibility/2006">
-        <mc:Choice xmlns:a14="http://schemas.microsoft.com/office/drawing/2010/main" Requires="a14">
+      <mc:AlternateContent xmlns:mc="http://schemas.openxmlformats.org/markup-compatibility/2006" xmlns:a14="http://schemas.microsoft.com/office/drawing/2010/main">
+        <mc:Choice Requires="a14">
           <p:sp>
             <p:nvSpPr>
               <p:cNvPr id="71" name="TextBox 70">
@@ -5180,6 +5181,7 @@
               </a:bodyPr>
               <a:lstStyle/>
               <a:p>
+                <a:pPr/>
                 <a14:m>
                   <m:oMathPara xmlns:m="http://schemas.openxmlformats.org/officeDocument/2006/math">
                     <m:oMathParaPr>
@@ -5365,7 +5367,7 @@
             </p:txBody>
           </p:sp>
         </mc:Choice>
-        <mc:Fallback>
+        <mc:Fallback xmlns="">
           <p:sp>
             <p:nvSpPr>
               <p:cNvPr id="71" name="TextBox 70">
@@ -5578,8 +5580,8 @@
           </a:fontRef>
         </p:style>
       </p:cxnSp>
-      <mc:AlternateContent xmlns:mc="http://schemas.openxmlformats.org/markup-compatibility/2006">
-        <mc:Choice xmlns:a14="http://schemas.microsoft.com/office/drawing/2010/main" Requires="a14">
+      <mc:AlternateContent xmlns:mc="http://schemas.openxmlformats.org/markup-compatibility/2006" xmlns:a14="http://schemas.microsoft.com/office/drawing/2010/main">
+        <mc:Choice Requires="a14">
           <p:sp>
             <p:nvSpPr>
               <p:cNvPr id="78" name="TextBox 77">
@@ -5628,11 +5630,12 @@
                     </m:r>
                   </m:oMath>
                 </a14:m>
+                <a:endParaRPr lang="en-US" sz="1100" dirty="0"/>
               </a:p>
             </p:txBody>
           </p:sp>
         </mc:Choice>
-        <mc:Fallback>
+        <mc:Fallback xmlns="">
           <p:sp>
             <p:nvSpPr>
               <p:cNvPr id="78" name="TextBox 77">
@@ -5677,8 +5680,8 @@
           </p:sp>
         </mc:Fallback>
       </mc:AlternateContent>
-      <mc:AlternateContent xmlns:mc="http://schemas.openxmlformats.org/markup-compatibility/2006">
-        <mc:Choice xmlns:a14="http://schemas.microsoft.com/office/drawing/2010/main" Requires="a14">
+      <mc:AlternateContent xmlns:mc="http://schemas.openxmlformats.org/markup-compatibility/2006" xmlns:a14="http://schemas.microsoft.com/office/drawing/2010/main">
+        <mc:Choice Requires="a14">
           <p:sp>
             <p:nvSpPr>
               <p:cNvPr id="79" name="TextBox 78">
@@ -5727,11 +5730,12 @@
                     </m:r>
                   </m:oMath>
                 </a14:m>
+                <a:endParaRPr lang="en-US" sz="1100" dirty="0"/>
               </a:p>
             </p:txBody>
           </p:sp>
         </mc:Choice>
-        <mc:Fallback>
+        <mc:Fallback xmlns="">
           <p:sp>
             <p:nvSpPr>
               <p:cNvPr id="79" name="TextBox 78">
@@ -5814,8 +5818,8 @@
           </a:fontRef>
         </p:style>
       </p:cxnSp>
-      <mc:AlternateContent xmlns:mc="http://schemas.openxmlformats.org/markup-compatibility/2006">
-        <mc:Choice xmlns:a14="http://schemas.microsoft.com/office/drawing/2010/main" Requires="a14">
+      <mc:AlternateContent xmlns:mc="http://schemas.openxmlformats.org/markup-compatibility/2006" xmlns:a14="http://schemas.microsoft.com/office/drawing/2010/main">
+        <mc:Choice Requires="a14">
           <p:sp>
             <p:nvSpPr>
               <p:cNvPr id="85" name="TextBox 84">
@@ -5856,6 +5860,7 @@
                 </a:r>
               </a:p>
               <a:p>
+                <a:pPr/>
                 <a14:m>
                   <m:oMathPara xmlns:m="http://schemas.openxmlformats.org/officeDocument/2006/math">
                     <m:oMathParaPr>
@@ -5883,11 +5888,12 @@
                     </m:oMath>
                   </m:oMathPara>
                 </a14:m>
+                <a:endParaRPr lang="en-US" sz="1100" dirty="0"/>
               </a:p>
             </p:txBody>
           </p:sp>
         </mc:Choice>
-        <mc:Fallback>
+        <mc:Fallback xmlns="">
           <p:sp>
             <p:nvSpPr>
               <p:cNvPr id="85" name="TextBox 84">
@@ -5932,8 +5938,8 @@
           </p:sp>
         </mc:Fallback>
       </mc:AlternateContent>
-      <mc:AlternateContent xmlns:mc="http://schemas.openxmlformats.org/markup-compatibility/2006">
-        <mc:Choice xmlns:a14="http://schemas.microsoft.com/office/drawing/2010/main" Requires="a14">
+      <mc:AlternateContent xmlns:mc="http://schemas.openxmlformats.org/markup-compatibility/2006" xmlns:a14="http://schemas.microsoft.com/office/drawing/2010/main">
+        <mc:Choice Requires="a14">
           <p:sp>
             <p:nvSpPr>
               <p:cNvPr id="86" name="TextBox 85">
@@ -6000,11 +6006,12 @@
                     </m:r>
                   </m:oMath>
                 </a14:m>
+                <a:endParaRPr lang="en-US" sz="1100" dirty="0"/>
               </a:p>
             </p:txBody>
           </p:sp>
         </mc:Choice>
-        <mc:Fallback>
+        <mc:Fallback xmlns="">
           <p:sp>
             <p:nvSpPr>
               <p:cNvPr id="86" name="TextBox 85">

</xml_diff>